<commit_message>
Ignore a crane mentioned only as crane access; refresh results and deck
"A section of guardrail had been removed for crane access" added Lifting
operation / crane to a slab-edge slip, and with it the corrective action
"Suspend lifts until the lift plan is reviewed". Triage now ignores the
phrase "crane access"; a crane that is part of what happened (a lost load,
an overturn, a slinger for the crane lift) is still a lifting operation.

No dev, held-out or seed label changes except SG-2026-0015, so the
evaluation is unchanged. Resolve-all regenerated on PostgreSQL: 21/21
closed, 107 runs, 0 failures, 79 decisions (64 approved, 15 rejected).
The Review III findings slide now uses this run and a new dashboard image.

Co-Authored-By: Claude Opus 5.5 <noreply@anthropic.com>
Claude-Session: https://claude.ai/code/session_01A3amu7D2RCCdRJjBi6ykVH
</commit_message>
<xml_diff>
--- a/docs/presentation/SiteGuardAI_Review3_S.K.Sricharan_T9984.pptx
+++ b/docs/presentation/SiteGuardAI_Review3_S.K.Sricharan_T9984.pptx
@@ -8912,7 +8912,7 @@
                           </a:solidFill>
                           <a:latin typeface="Calibri"/>
                         </a:rPr>
-                        <a:t>24</a:t>
+                        <a:t>15</a:t>
                       </a:r>
                     </a:p>
                   </a:txBody>
@@ -8983,7 +8983,7 @@
                           </a:solidFill>
                           <a:latin typeface="Calibri"/>
                         </a:rPr>
-                        <a:t>6</a:t>
+                        <a:t>4</a:t>
                       </a:r>
                     </a:p>
                   </a:txBody>
@@ -9221,7 +9221,7 @@
                 </a:solidFill>
                 <a:latin typeface="Calibri"/>
               </a:rPr>
-              <a:t>80</a:t>
+              <a:t>79</a:t>
             </a:r>
           </a:p>
           <a:p>
@@ -9237,7 +9237,7 @@
                 </a:solidFill>
                 <a:latin typeface="Calibri"/>
               </a:rPr>
-              <a:t>human decisions: 65 approved, 15 rejected</a:t>
+              <a:t>human decisions: 64 approved, 15 rejected</a:t>
             </a:r>
           </a:p>
         </p:txBody>

</xml_diff>

<commit_message>
Fresh README screenshots; Review III deck with the product screens
docs/screenshots/ recaptured by the browser end-to-end run on current main,
so the action queue no longer shows the lift-plan action removed by the
crane-access fix.

The Review III deck grows to 18 slides: two findings slides show the
product in use from the same run (AI investigation, action queue,
verified closure; grounded answer, photo review, audit trail). The
performance slide and the README quick start now give 267 backend tests;
every other figure was re-checked against EVALUATION.md, RESULTS.md and
LOAD_TEST.md.

Co-Authored-By: Claude Opus 5.5 <noreply@anthropic.com>
Claude-Session: https://claude.ai/code/session_01A3amu7D2RCCdRJjBi6ykVH
</commit_message>
<xml_diff>
--- a/docs/presentation/SiteGuardAI_Review3_S.K.Sricharan_T9984.pptx
+++ b/docs/presentation/SiteGuardAI_Review3_S.K.Sricharan_T9984.pptx
@@ -17,6 +17,8 @@
     <p:sldId id="2147470498" r:id="rId8"/>
     <p:sldId id="2147470497" r:id="rId9"/>
     <p:sldId id="2147470508" r:id="rId21"/>
+    <p:sldId id="2147470510" r:id="rId23"/>
+    <p:sldId id="2147470509" r:id="rId22"/>
     <p:sldId id="2147470507" r:id="rId20"/>
     <p:sldId id="2147470499" r:id="rId10"/>
     <p:sldId id="2147470502" r:id="rId11"/>
@@ -1178,7 +1180,7 @@
           <a:lstStyle/>
           <a:p>
             <a:r>
-              <a:t>Load test of the production image on PostgreSQL 16 (one API process, 4 vCPU host) and the quality gates that run on every change.</a:t>
+              <a:t>Screens from the running product (browser end-to-end run on main). AI output is labelled; actions wait for the HSE manager; closure needs verified actions.</a:t>
             </a:r>
           </a:p>
         </p:txBody>
@@ -1204,6 +1206,146 @@
 </file>
 
 <file path=ppt/notesSlides/notesSlide14.xml><?xml version="1.0" encoding="utf-8"?>
+<p:notes xmlns:a="http://schemas.openxmlformats.org/drawingml/2006/main" xmlns:p="http://schemas.openxmlformats.org/presentationml/2006/main" xmlns:r="http://schemas.openxmlformats.org/officeDocument/2006/relationships">
+  <p:cSld>
+    <p:spTree>
+      <p:nvGrpSpPr>
+        <p:cNvPr id="1" name=""/>
+        <p:cNvGrpSpPr/>
+        <p:nvPr/>
+      </p:nvGrpSpPr>
+      <p:grpSpPr>
+        <a:xfrm>
+          <a:off x="0" y="0"/>
+          <a:ext cx="0" cy="0"/>
+          <a:chOff x="0" y="0"/>
+          <a:chExt cx="0" cy="0"/>
+        </a:xfrm>
+      </p:grpSpPr>
+      <p:sp>
+        <p:nvSpPr>
+          <p:cNvPr id="2" name="Slide Image Placeholder 1"/>
+          <p:cNvSpPr>
+            <a:spLocks noGrp="1"/>
+          </p:cNvSpPr>
+          <p:nvPr>
+            <p:ph type="sldImg" idx="2"/>
+          </p:nvPr>
+        </p:nvSpPr>
+        <p:spPr/>
+      </p:sp>
+      <p:sp>
+        <p:nvSpPr>
+          <p:cNvPr id="3" name="Notes Placeholder 2"/>
+          <p:cNvSpPr>
+            <a:spLocks noGrp="1"/>
+          </p:cNvSpPr>
+          <p:nvPr>
+            <p:ph type="body" idx="3" sz="quarter"/>
+          </p:nvPr>
+        </p:nvSpPr>
+        <p:spPr/>
+        <p:txBody>
+          <a:bodyPr/>
+          <a:lstStyle/>
+          <a:p>
+            <a:r>
+              <a:t>Grounded answers cite the procedure passage they come from; photo findings are suggestions for an engineer; every action is in the audit trail.</a:t>
+            </a:r>
+          </a:p>
+        </p:txBody>
+      </p:sp>
+      <p:sp>
+        <p:nvSpPr>
+          <p:cNvPr id="4" name="Slide Number Placeholder 3"/>
+          <p:cNvSpPr>
+            <a:spLocks noGrp="1"/>
+          </p:cNvSpPr>
+          <p:nvPr>
+            <p:ph type="sldNum" idx="5" sz="quarter"/>
+          </p:nvPr>
+        </p:nvSpPr>
+        <p:spPr/>
+      </p:sp>
+    </p:spTree>
+  </p:cSld>
+  <p:clrMapOvr>
+    <a:masterClrMapping/>
+  </p:clrMapOvr>
+</p:notes>
+</file>
+
+<file path=ppt/notesSlides/notesSlide15.xml><?xml version="1.0" encoding="utf-8"?>
+<p:notes xmlns:a="http://schemas.openxmlformats.org/drawingml/2006/main" xmlns:p="http://schemas.openxmlformats.org/presentationml/2006/main" xmlns:r="http://schemas.openxmlformats.org/officeDocument/2006/relationships">
+  <p:cSld>
+    <p:spTree>
+      <p:nvGrpSpPr>
+        <p:cNvPr id="1" name=""/>
+        <p:cNvGrpSpPr/>
+        <p:nvPr/>
+      </p:nvGrpSpPr>
+      <p:grpSpPr>
+        <a:xfrm>
+          <a:off x="0" y="0"/>
+          <a:ext cx="0" cy="0"/>
+          <a:chOff x="0" y="0"/>
+          <a:chExt cx="0" cy="0"/>
+        </a:xfrm>
+      </p:grpSpPr>
+      <p:sp>
+        <p:nvSpPr>
+          <p:cNvPr id="2" name="Slide Image Placeholder 1"/>
+          <p:cNvSpPr>
+            <a:spLocks noGrp="1"/>
+          </p:cNvSpPr>
+          <p:nvPr>
+            <p:ph type="sldImg" idx="2"/>
+          </p:nvPr>
+        </p:nvSpPr>
+        <p:spPr/>
+      </p:sp>
+      <p:sp>
+        <p:nvSpPr>
+          <p:cNvPr id="3" name="Notes Placeholder 2"/>
+          <p:cNvSpPr>
+            <a:spLocks noGrp="1"/>
+          </p:cNvSpPr>
+          <p:nvPr>
+            <p:ph type="body" idx="3" sz="quarter"/>
+          </p:nvPr>
+        </p:nvSpPr>
+        <p:spPr/>
+        <p:txBody>
+          <a:bodyPr/>
+          <a:lstStyle/>
+          <a:p>
+            <a:r>
+              <a:t>Load test of the production image on PostgreSQL 16 (one API process, 4 vCPU host) and the quality gates that run on every change.</a:t>
+            </a:r>
+          </a:p>
+        </p:txBody>
+      </p:sp>
+      <p:sp>
+        <p:nvSpPr>
+          <p:cNvPr id="4" name="Slide Number Placeholder 3"/>
+          <p:cNvSpPr>
+            <a:spLocks noGrp="1"/>
+          </p:cNvSpPr>
+          <p:nvPr>
+            <p:ph type="sldNum" idx="5" sz="quarter"/>
+          </p:nvPr>
+        </p:nvSpPr>
+        <p:spPr/>
+      </p:sp>
+    </p:spTree>
+  </p:cSld>
+  <p:clrMapOvr>
+    <a:masterClrMapping/>
+  </p:clrMapOvr>
+</p:notes>
+</file>
+
+<file path=ppt/notesSlides/notesSlide16.xml><?xml version="1.0" encoding="utf-8"?>
 <p:notes xmlns:a="http://schemas.openxmlformats.org/drawingml/2006/main" xmlns:p="http://schemas.openxmlformats.org/presentationml/2006/main" xmlns:r="http://schemas.openxmlformats.org/officeDocument/2006/relationships">
   <p:cSld>
     <p:spTree>
@@ -9404,6 +9546,864 @@
 </file>
 
 <file path=ppt/slides/slide13.xml><?xml version="1.0" encoding="utf-8"?>
+<p:sld xmlns:a="http://schemas.openxmlformats.org/drawingml/2006/main" xmlns:r="http://schemas.openxmlformats.org/officeDocument/2006/relationships" xmlns:p="http://schemas.openxmlformats.org/presentationml/2006/main">
+  <p:cSld>
+    <p:spTree>
+      <p:nvGrpSpPr>
+        <p:cNvPr id="1" name="">
+          <a:extLst>
+            <a:ext uri="{FF2B5EF4-FFF2-40B4-BE49-F238E27FC236}">
+              <a16:creationId xmlns:a16="http://schemas.microsoft.com/office/drawing/2014/main" id="{149CEA2B-384E-F256-4734-5578EDB524A9}"/>
+            </a:ext>
+          </a:extLst>
+        </p:cNvPr>
+        <p:cNvGrpSpPr/>
+        <p:nvPr/>
+      </p:nvGrpSpPr>
+      <p:grpSpPr>
+        <a:xfrm>
+          <a:off x="0" y="0"/>
+          <a:ext cx="0" cy="0"/>
+          <a:chOff x="0" y="0"/>
+          <a:chExt cx="0" cy="0"/>
+        </a:xfrm>
+      </p:grpSpPr>
+      <p:sp>
+        <p:nvSpPr>
+          <p:cNvPr id="3" name="TextBox 2">
+            <a:extLst>
+              <a:ext uri="{FF2B5EF4-FFF2-40B4-BE49-F238E27FC236}">
+                <a16:creationId xmlns:a16="http://schemas.microsoft.com/office/drawing/2014/main" id="{3411E118-0427-BF72-3B78-1707B0D6E382}"/>
+              </a:ext>
+            </a:extLst>
+          </p:cNvPr>
+          <p:cNvSpPr txBox="1"/>
+          <p:nvPr/>
+        </p:nvSpPr>
+        <p:spPr>
+          <a:xfrm>
+            <a:off x="255996" y="502545"/>
+            <a:ext cx="10624338" cy="646331"/>
+          </a:xfrm>
+          <a:prstGeom prst="rect">
+            <a:avLst/>
+          </a:prstGeom>
+          <a:noFill/>
+        </p:spPr>
+        <p:txBody>
+          <a:bodyPr wrap="square" rtlCol="0">
+            <a:spAutoFit/>
+          </a:bodyPr>
+          <a:lstStyle/>
+          <a:p>
+            <a:pPr lvl="0">
+              <a:defRPr/>
+            </a:pPr>
+            <a:r>
+              <a:rPr lang="en-US" sz="3200" b="1" dirty="0">
+                <a:solidFill>
+                  <a:srgbClr val="5B9BD5">
+                    <a:lumMod val="50000"/>
+                  </a:srgbClr>
+                </a:solidFill>
+              </a:rPr>
+              <a:t>Findings – The Product: Investigation to Closure</a:t>
+            </a:r>
+          </a:p>
+        </p:txBody>
+      </p:sp>
+      <p:cxnSp>
+        <p:nvCxnSpPr>
+          <p:cNvPr id="5" name="Straight Connector 4">
+            <a:extLst>
+              <a:ext uri="{FF2B5EF4-FFF2-40B4-BE49-F238E27FC236}">
+                <a16:creationId xmlns:a16="http://schemas.microsoft.com/office/drawing/2014/main" id="{7A5618F6-CE69-311A-F79A-D12C7E917449}"/>
+              </a:ext>
+            </a:extLst>
+          </p:cNvPr>
+          <p:cNvCxnSpPr>
+            <a:cxnSpLocks/>
+          </p:cNvCxnSpPr>
+          <p:nvPr/>
+        </p:nvCxnSpPr>
+        <p:spPr>
+          <a:xfrm>
+            <a:off x="221274" y="1191756"/>
+            <a:ext cx="7305799" cy="0"/>
+          </a:xfrm>
+          <a:prstGeom prst="line">
+            <a:avLst/>
+          </a:prstGeom>
+          <a:ln w="28575">
+            <a:solidFill>
+              <a:schemeClr val="accent6"/>
+            </a:solidFill>
+          </a:ln>
+        </p:spPr>
+        <p:style>
+          <a:lnRef idx="1">
+            <a:schemeClr val="accent1"/>
+          </a:lnRef>
+          <a:fillRef idx="0">
+            <a:schemeClr val="accent1"/>
+          </a:fillRef>
+          <a:effectRef idx="0">
+            <a:schemeClr val="accent1"/>
+          </a:effectRef>
+          <a:fontRef idx="minor">
+            <a:schemeClr val="tx1"/>
+          </a:fontRef>
+        </p:style>
+      </p:cxnSp>
+      <p:sp>
+        <p:nvSpPr>
+          <p:cNvPr id="4" name="TextBox 3">
+            <a:extLst>
+              <a:ext uri="{FF2B5EF4-FFF2-40B4-BE49-F238E27FC236}">
+                <a16:creationId xmlns:a16="http://schemas.microsoft.com/office/drawing/2014/main" id="{64F7A196-7B69-DD68-52A5-39CD9B799F7D}"/>
+              </a:ext>
+            </a:extLst>
+          </p:cNvPr>
+          <p:cNvSpPr txBox="1"/>
+          <p:nvPr/>
+        </p:nvSpPr>
+        <p:spPr>
+          <a:xfrm>
+            <a:off x="3977639" y="57036"/>
+            <a:ext cx="8092440" cy="646331"/>
+          </a:xfrm>
+          <a:prstGeom prst="rect">
+            <a:avLst/>
+          </a:prstGeom>
+          <a:noFill/>
+        </p:spPr>
+        <p:txBody>
+          <a:bodyPr wrap="square" rtlCol="0">
+            <a:spAutoFit/>
+          </a:bodyPr>
+          <a:lstStyle/>
+          <a:p>
+            <a:pPr algn="r"/>
+            <a:r>
+              <a:rPr lang="en-US" sz="1300" b="1" i="1" dirty="0">
+                <a:solidFill>
+                  <a:srgbClr val="FFFFFF"/>
+                </a:solidFill>
+                <a:latin typeface="Calibri"/>
+              </a:rPr>
+              <a:t>Site Guard AI: Multi-Agent Construction Safety &amp; Quality Incident Resolution System</a:t>
+            </a:r>
+          </a:p>
+        </p:txBody>
+      </p:sp>
+      <p:pic>
+        <p:nvPicPr>
+          <p:cNvPr id="6" name="Picture 5" descr="s_workspace.png"/>
+          <p:cNvPicPr>
+            <a:picLocks noChangeAspect="1"/>
+          </p:cNvPicPr>
+          <p:nvPr/>
+        </p:nvPicPr>
+        <p:blipFill>
+          <a:blip r:embed="rId3"/>
+          <a:stretch>
+            <a:fillRect/>
+          </a:stretch>
+        </p:blipFill>
+        <p:spPr>
+          <a:xfrm>
+            <a:off x="411480" y="1280160"/>
+            <a:ext cx="5120640" cy="3600450"/>
+          </a:xfrm>
+          <a:prstGeom prst="rect">
+            <a:avLst/>
+          </a:prstGeom>
+          <a:ln w="9525">
+            <a:solidFill>
+              <a:srgbClr val="D1D5DB"/>
+            </a:solidFill>
+          </a:ln>
+        </p:spPr>
+      </p:pic>
+      <p:sp>
+        <p:nvSpPr>
+          <p:cNvPr id="7" name="TextBox 6"/>
+          <p:cNvSpPr txBox="1"/>
+          <p:nvPr/>
+        </p:nvSpPr>
+        <p:spPr>
+          <a:xfrm>
+            <a:off x="411480" y="4898898"/>
+            <a:ext cx="5120640" cy="274320"/>
+          </a:xfrm>
+          <a:prstGeom prst="rect">
+            <a:avLst/>
+          </a:prstGeom>
+          <a:noFill/>
+        </p:spPr>
+        <p:txBody>
+          <a:bodyPr wrap="square" anchor="t" lIns="73152" rIns="73152" tIns="73152" bIns="73152"/>
+          <a:lstStyle/>
+          <a:p>
+            <a:pPr algn="l">
+              <a:spcAft>
+                <a:spcPts val="400"/>
+              </a:spcAft>
+            </a:pPr>
+            <a:r>
+              <a:rPr sz="1100" b="0">
+                <a:solidFill>
+                  <a:srgbClr val="4B5563"/>
+                </a:solidFill>
+                <a:latin typeface="Calibri"/>
+              </a:rPr>
+              <a:t>AI investigation of a new report: triage, safety findings, 5×5 risk, root causes, all marked AI-generated</a:t>
+            </a:r>
+          </a:p>
+        </p:txBody>
+      </p:sp>
+      <p:pic>
+        <p:nvPicPr>
+          <p:cNvPr id="8" name="Picture 7" descr="s_queue.png"/>
+          <p:cNvPicPr>
+            <a:picLocks noChangeAspect="1"/>
+          </p:cNvPicPr>
+          <p:nvPr/>
+        </p:nvPicPr>
+        <p:blipFill>
+          <a:blip r:embed="rId4"/>
+          <a:stretch>
+            <a:fillRect/>
+          </a:stretch>
+        </p:blipFill>
+        <p:spPr>
+          <a:xfrm>
+            <a:off x="5760720" y="1280160"/>
+            <a:ext cx="6035040" cy="1555909"/>
+          </a:xfrm>
+          <a:prstGeom prst="rect">
+            <a:avLst/>
+          </a:prstGeom>
+          <a:ln w="9525">
+            <a:solidFill>
+              <a:srgbClr val="D1D5DB"/>
+            </a:solidFill>
+          </a:ln>
+        </p:spPr>
+      </p:pic>
+      <p:sp>
+        <p:nvSpPr>
+          <p:cNvPr id="9" name="TextBox 8"/>
+          <p:cNvSpPr txBox="1"/>
+          <p:nvPr/>
+        </p:nvSpPr>
+        <p:spPr>
+          <a:xfrm>
+            <a:off x="5760720" y="2854356"/>
+            <a:ext cx="6035040" cy="274320"/>
+          </a:xfrm>
+          <a:prstGeom prst="rect">
+            <a:avLst/>
+          </a:prstGeom>
+          <a:noFill/>
+        </p:spPr>
+        <p:txBody>
+          <a:bodyPr wrap="square" anchor="t" lIns="73152" rIns="73152" tIns="73152" bIns="73152"/>
+          <a:lstStyle/>
+          <a:p>
+            <a:pPr algn="l">
+              <a:spcAft>
+                <a:spcPts val="400"/>
+              </a:spcAft>
+            </a:pPr>
+            <a:r>
+              <a:rPr sz="1100" b="0">
+                <a:solidFill>
+                  <a:srgbClr val="4B5563"/>
+                </a:solidFill>
+                <a:latin typeface="Calibri"/>
+              </a:rPr>
+              <a:t>Action queue: every AI-proposed action waits for a person; critical ones only for the HSE manager</a:t>
+            </a:r>
+          </a:p>
+        </p:txBody>
+      </p:sp>
+      <p:pic>
+        <p:nvPicPr>
+          <p:cNvPr id="10" name="Picture 9" descr="s_closed.png"/>
+          <p:cNvPicPr>
+            <a:picLocks noChangeAspect="1"/>
+          </p:cNvPicPr>
+          <p:nvPr/>
+        </p:nvPicPr>
+        <p:blipFill>
+          <a:blip r:embed="rId5"/>
+          <a:stretch>
+            <a:fillRect/>
+          </a:stretch>
+        </p:blipFill>
+        <p:spPr>
+          <a:xfrm>
+            <a:off x="5760720" y="3201828"/>
+            <a:ext cx="6035040" cy="2074545"/>
+          </a:xfrm>
+          <a:prstGeom prst="rect">
+            <a:avLst/>
+          </a:prstGeom>
+          <a:ln w="9525">
+            <a:solidFill>
+              <a:srgbClr val="D1D5DB"/>
+            </a:solidFill>
+          </a:ln>
+        </p:spPr>
+      </p:pic>
+      <p:sp>
+        <p:nvSpPr>
+          <p:cNvPr id="11" name="TextBox 10"/>
+          <p:cNvSpPr txBox="1"/>
+          <p:nvPr/>
+        </p:nvSpPr>
+        <p:spPr>
+          <a:xfrm>
+            <a:off x="5760720" y="5294661"/>
+            <a:ext cx="6035040" cy="274320"/>
+          </a:xfrm>
+          <a:prstGeom prst="rect">
+            <a:avLst/>
+          </a:prstGeom>
+          <a:noFill/>
+        </p:spPr>
+        <p:txBody>
+          <a:bodyPr wrap="square" anchor="t" lIns="73152" rIns="73152" tIns="73152" bIns="73152"/>
+          <a:lstStyle/>
+          <a:p>
+            <a:pPr algn="l">
+              <a:spcAft>
+                <a:spcPts val="400"/>
+              </a:spcAft>
+            </a:pPr>
+            <a:r>
+              <a:rPr sz="1100" b="0">
+                <a:solidFill>
+                  <a:srgbClr val="4B5563"/>
+                </a:solidFill>
+                <a:latin typeface="Calibri"/>
+              </a:rPr>
+              <a:t>The same incident closed, only after each approved action was verified effective</a:t>
+            </a:r>
+          </a:p>
+        </p:txBody>
+      </p:sp>
+    </p:spTree>
+    <p:extLst>
+      <p:ext uri="{BB962C8B-B14F-4D97-AF65-F5344CB8AC3E}">
+        <p14:creationId xmlns:p14="http://schemas.microsoft.com/office/powerpoint/2010/main" val="679362563"/>
+      </p:ext>
+    </p:extLst>
+  </p:cSld>
+  <p:clrMapOvr>
+    <a:masterClrMapping/>
+  </p:clrMapOvr>
+  <mc:AlternateContent xmlns:mc="http://schemas.openxmlformats.org/markup-compatibility/2006" xmlns:p14="http://schemas.microsoft.com/office/powerpoint/2010/main">
+    <mc:Choice Requires="p14">
+      <p:transition spd="med" p14:dur="700">
+        <p:fade/>
+      </p:transition>
+    </mc:Choice>
+    <mc:Fallback xmlns="">
+      <p:transition spd="med">
+        <p:fade/>
+      </p:transition>
+    </mc:Fallback>
+  </mc:AlternateContent>
+</p:sld>
+</file>
+
+<file path=ppt/slides/slide14.xml><?xml version="1.0" encoding="utf-8"?>
+<p:sld xmlns:a="http://schemas.openxmlformats.org/drawingml/2006/main" xmlns:r="http://schemas.openxmlformats.org/officeDocument/2006/relationships" xmlns:p="http://schemas.openxmlformats.org/presentationml/2006/main">
+  <p:cSld>
+    <p:spTree>
+      <p:nvGrpSpPr>
+        <p:cNvPr id="1" name="">
+          <a:extLst>
+            <a:ext uri="{FF2B5EF4-FFF2-40B4-BE49-F238E27FC236}">
+              <a16:creationId xmlns:a16="http://schemas.microsoft.com/office/drawing/2014/main" id="{149CEA2B-384E-F256-4734-5578EDB524A9}"/>
+            </a:ext>
+          </a:extLst>
+        </p:cNvPr>
+        <p:cNvGrpSpPr/>
+        <p:nvPr/>
+      </p:nvGrpSpPr>
+      <p:grpSpPr>
+        <a:xfrm>
+          <a:off x="0" y="0"/>
+          <a:ext cx="0" cy="0"/>
+          <a:chOff x="0" y="0"/>
+          <a:chExt cx="0" cy="0"/>
+        </a:xfrm>
+      </p:grpSpPr>
+      <p:sp>
+        <p:nvSpPr>
+          <p:cNvPr id="3" name="TextBox 2">
+            <a:extLst>
+              <a:ext uri="{FF2B5EF4-FFF2-40B4-BE49-F238E27FC236}">
+                <a16:creationId xmlns:a16="http://schemas.microsoft.com/office/drawing/2014/main" id="{3411E118-0427-BF72-3B78-1707B0D6E382}"/>
+              </a:ext>
+            </a:extLst>
+          </p:cNvPr>
+          <p:cNvSpPr txBox="1"/>
+          <p:nvPr/>
+        </p:nvSpPr>
+        <p:spPr>
+          <a:xfrm>
+            <a:off x="255996" y="502545"/>
+            <a:ext cx="10624338" cy="646331"/>
+          </a:xfrm>
+          <a:prstGeom prst="rect">
+            <a:avLst/>
+          </a:prstGeom>
+          <a:noFill/>
+        </p:spPr>
+        <p:txBody>
+          <a:bodyPr wrap="square" rtlCol="0">
+            <a:spAutoFit/>
+          </a:bodyPr>
+          <a:lstStyle/>
+          <a:p>
+            <a:pPr lvl="0">
+              <a:defRPr/>
+            </a:pPr>
+            <a:r>
+              <a:rPr lang="en-US" sz="3200" b="1" dirty="0">
+                <a:solidFill>
+                  <a:srgbClr val="5B9BD5">
+                    <a:lumMod val="50000"/>
+                  </a:srgbClr>
+                </a:solidFill>
+              </a:rPr>
+              <a:t>Findings – The Product: Knowledge, Photos &amp; Audit</a:t>
+            </a:r>
+          </a:p>
+        </p:txBody>
+      </p:sp>
+      <p:cxnSp>
+        <p:nvCxnSpPr>
+          <p:cNvPr id="5" name="Straight Connector 4">
+            <a:extLst>
+              <a:ext uri="{FF2B5EF4-FFF2-40B4-BE49-F238E27FC236}">
+                <a16:creationId xmlns:a16="http://schemas.microsoft.com/office/drawing/2014/main" id="{7A5618F6-CE69-311A-F79A-D12C7E917449}"/>
+              </a:ext>
+            </a:extLst>
+          </p:cNvPr>
+          <p:cNvCxnSpPr>
+            <a:cxnSpLocks/>
+          </p:cNvCxnSpPr>
+          <p:nvPr/>
+        </p:nvCxnSpPr>
+        <p:spPr>
+          <a:xfrm>
+            <a:off x="221274" y="1191756"/>
+            <a:ext cx="7305799" cy="0"/>
+          </a:xfrm>
+          <a:prstGeom prst="line">
+            <a:avLst/>
+          </a:prstGeom>
+          <a:ln w="28575">
+            <a:solidFill>
+              <a:schemeClr val="accent6"/>
+            </a:solidFill>
+          </a:ln>
+        </p:spPr>
+        <p:style>
+          <a:lnRef idx="1">
+            <a:schemeClr val="accent1"/>
+          </a:lnRef>
+          <a:fillRef idx="0">
+            <a:schemeClr val="accent1"/>
+          </a:fillRef>
+          <a:effectRef idx="0">
+            <a:schemeClr val="accent1"/>
+          </a:effectRef>
+          <a:fontRef idx="minor">
+            <a:schemeClr val="tx1"/>
+          </a:fontRef>
+        </p:style>
+      </p:cxnSp>
+      <p:sp>
+        <p:nvSpPr>
+          <p:cNvPr id="4" name="TextBox 3">
+            <a:extLst>
+              <a:ext uri="{FF2B5EF4-FFF2-40B4-BE49-F238E27FC236}">
+                <a16:creationId xmlns:a16="http://schemas.microsoft.com/office/drawing/2014/main" id="{64F7A196-7B69-DD68-52A5-39CD9B799F7D}"/>
+              </a:ext>
+            </a:extLst>
+          </p:cNvPr>
+          <p:cNvSpPr txBox="1"/>
+          <p:nvPr/>
+        </p:nvSpPr>
+        <p:spPr>
+          <a:xfrm>
+            <a:off x="3977639" y="57036"/>
+            <a:ext cx="8092440" cy="646331"/>
+          </a:xfrm>
+          <a:prstGeom prst="rect">
+            <a:avLst/>
+          </a:prstGeom>
+          <a:noFill/>
+        </p:spPr>
+        <p:txBody>
+          <a:bodyPr wrap="square" rtlCol="0">
+            <a:spAutoFit/>
+          </a:bodyPr>
+          <a:lstStyle/>
+          <a:p>
+            <a:pPr algn="r"/>
+            <a:r>
+              <a:rPr lang="en-US" sz="1300" b="1" i="1" dirty="0">
+                <a:solidFill>
+                  <a:srgbClr val="FFFFFF"/>
+                </a:solidFill>
+                <a:latin typeface="Calibri"/>
+              </a:rPr>
+              <a:t>Site Guard AI: Multi-Agent Construction Safety &amp; Quality Incident Resolution System</a:t>
+            </a:r>
+          </a:p>
+        </p:txBody>
+      </p:sp>
+      <p:pic>
+        <p:nvPicPr>
+          <p:cNvPr id="6" name="Picture 5" descr="s_answer.png"/>
+          <p:cNvPicPr>
+            <a:picLocks noChangeAspect="1"/>
+          </p:cNvPicPr>
+          <p:nvPr/>
+        </p:nvPicPr>
+        <p:blipFill>
+          <a:blip r:embed="rId3"/>
+          <a:stretch>
+            <a:fillRect/>
+          </a:stretch>
+        </p:blipFill>
+        <p:spPr>
+          <a:xfrm>
+            <a:off x="411480" y="1280160"/>
+            <a:ext cx="5715000" cy="1674316"/>
+          </a:xfrm>
+          <a:prstGeom prst="rect">
+            <a:avLst/>
+          </a:prstGeom>
+          <a:ln w="9525">
+            <a:solidFill>
+              <a:srgbClr val="D1D5DB"/>
+            </a:solidFill>
+          </a:ln>
+        </p:spPr>
+      </p:pic>
+      <p:sp>
+        <p:nvSpPr>
+          <p:cNvPr id="7" name="TextBox 6"/>
+          <p:cNvSpPr txBox="1"/>
+          <p:nvPr/>
+        </p:nvSpPr>
+        <p:spPr>
+          <a:xfrm>
+            <a:off x="411480" y="2972764"/>
+            <a:ext cx="5715000" cy="274320"/>
+          </a:xfrm>
+          <a:prstGeom prst="rect">
+            <a:avLst/>
+          </a:prstGeom>
+          <a:noFill/>
+        </p:spPr>
+        <p:txBody>
+          <a:bodyPr wrap="square" anchor="t" lIns="73152" rIns="73152" tIns="73152" bIns="73152"/>
+          <a:lstStyle/>
+          <a:p>
+            <a:pPr algn="l">
+              <a:spcAft>
+                <a:spcPts val="400"/>
+              </a:spcAft>
+            </a:pPr>
+            <a:r>
+              <a:rPr sz="1100" b="0">
+                <a:solidFill>
+                  <a:srgbClr val="4B5563"/>
+                </a:solidFill>
+                <a:latin typeface="Calibri"/>
+              </a:rPr>
+              <a:t>Grounded answer: each statement cites its source passage, or says the documents do not answer</a:t>
+            </a:r>
+          </a:p>
+        </p:txBody>
+      </p:sp>
+      <p:pic>
+        <p:nvPicPr>
+          <p:cNvPr id="8" name="Picture 7" descr="s_audit.png"/>
+          <p:cNvPicPr>
+            <a:picLocks noChangeAspect="1"/>
+          </p:cNvPicPr>
+          <p:nvPr/>
+        </p:nvPicPr>
+        <p:blipFill>
+          <a:blip r:embed="rId4"/>
+          <a:stretch>
+            <a:fillRect/>
+          </a:stretch>
+        </p:blipFill>
+        <p:spPr>
+          <a:xfrm>
+            <a:off x="411480" y="3338524"/>
+            <a:ext cx="5715000" cy="1875234"/>
+          </a:xfrm>
+          <a:prstGeom prst="rect">
+            <a:avLst/>
+          </a:prstGeom>
+          <a:ln w="9525">
+            <a:solidFill>
+              <a:srgbClr val="D1D5DB"/>
+            </a:solidFill>
+          </a:ln>
+        </p:spPr>
+      </p:pic>
+      <p:sp>
+        <p:nvSpPr>
+          <p:cNvPr id="9" name="TextBox 8"/>
+          <p:cNvSpPr txBox="1"/>
+          <p:nvPr/>
+        </p:nvSpPr>
+        <p:spPr>
+          <a:xfrm>
+            <a:off x="411480" y="5232046"/>
+            <a:ext cx="5715000" cy="274320"/>
+          </a:xfrm>
+          <a:prstGeom prst="rect">
+            <a:avLst/>
+          </a:prstGeom>
+          <a:noFill/>
+        </p:spPr>
+        <p:txBody>
+          <a:bodyPr wrap="square" anchor="t" lIns="73152" rIns="73152" tIns="73152" bIns="73152"/>
+          <a:lstStyle/>
+          <a:p>
+            <a:pPr algn="l">
+              <a:spcAft>
+                <a:spcPts val="400"/>
+              </a:spcAft>
+            </a:pPr>
+            <a:r>
+              <a:rPr sz="1100" b="0">
+                <a:solidFill>
+                  <a:srgbClr val="4B5563"/>
+                </a:solidFill>
+                <a:latin typeface="Calibri"/>
+              </a:rPr>
+              <a:t>Audit trail: every human and agent action with a correlation ID</a:t>
+            </a:r>
+          </a:p>
+        </p:txBody>
+      </p:sp>
+      <p:pic>
+        <p:nvPicPr>
+          <p:cNvPr id="10" name="Picture 9" descr="s_photo.png"/>
+          <p:cNvPicPr>
+            <a:picLocks noChangeAspect="1"/>
+          </p:cNvPicPr>
+          <p:nvPr/>
+        </p:nvPicPr>
+        <p:blipFill>
+          <a:blip r:embed="rId5"/>
+          <a:stretch>
+            <a:fillRect/>
+          </a:stretch>
+        </p:blipFill>
+        <p:spPr>
+          <a:xfrm>
+            <a:off x="6355080" y="1280160"/>
+            <a:ext cx="5440680" cy="2104130"/>
+          </a:xfrm>
+          <a:prstGeom prst="rect">
+            <a:avLst/>
+          </a:prstGeom>
+          <a:ln w="9525">
+            <a:solidFill>
+              <a:srgbClr val="D1D5DB"/>
+            </a:solidFill>
+          </a:ln>
+        </p:spPr>
+      </p:pic>
+      <p:sp>
+        <p:nvSpPr>
+          <p:cNvPr id="11" name="TextBox 10"/>
+          <p:cNvSpPr txBox="1"/>
+          <p:nvPr/>
+        </p:nvSpPr>
+        <p:spPr>
+          <a:xfrm>
+            <a:off x="6355080" y="3402578"/>
+            <a:ext cx="5440680" cy="274320"/>
+          </a:xfrm>
+          <a:prstGeom prst="rect">
+            <a:avLst/>
+          </a:prstGeom>
+          <a:noFill/>
+        </p:spPr>
+        <p:txBody>
+          <a:bodyPr wrap="square" anchor="t" lIns="73152" rIns="73152" tIns="73152" bIns="73152"/>
+          <a:lstStyle/>
+          <a:p>
+            <a:pPr algn="l">
+              <a:spcAft>
+                <a:spcPts val="400"/>
+              </a:spcAft>
+            </a:pPr>
+            <a:r>
+              <a:rPr sz="1100" b="0">
+                <a:solidFill>
+                  <a:srgbClr val="4B5563"/>
+                </a:solidFill>
+                <a:latin typeface="Calibri"/>
+              </a:rPr>
+              <a:t>Photo review: image checks for an engineer to confirm; never proof on their own</a:t>
+            </a:r>
+          </a:p>
+        </p:txBody>
+      </p:sp>
+      <p:sp>
+        <p:nvSpPr>
+          <p:cNvPr id="12" name="Rounded Rectangle 11"/>
+          <p:cNvSpPr/>
+          <p:nvPr/>
+        </p:nvSpPr>
+        <p:spPr>
+          <a:xfrm>
+            <a:off x="6355080" y="3786626"/>
+            <a:ext cx="5440680" cy="1471173"/>
+          </a:xfrm>
+          <a:prstGeom prst="roundRect">
+            <a:avLst>
+              <a:gd name="adj" fmla="val 8000"/>
+            </a:avLst>
+          </a:prstGeom>
+          <a:solidFill>
+            <a:srgbClr val="EEF5FB"/>
+          </a:solidFill>
+          <a:ln>
+            <a:noFill/>
+          </a:ln>
+          <a:effectLst/>
+        </p:spPr>
+        <p:style>
+          <a:lnRef idx="1">
+            <a:schemeClr val="accent1"/>
+          </a:lnRef>
+          <a:fillRef idx="3">
+            <a:schemeClr val="accent1"/>
+          </a:fillRef>
+          <a:effectRef idx="2">
+            <a:schemeClr val="accent1"/>
+          </a:effectRef>
+          <a:fontRef idx="minor">
+            <a:schemeClr val="lt1"/>
+          </a:fontRef>
+        </p:style>
+        <p:txBody>
+          <a:bodyPr rtlCol="0" anchor="ctr" wrap="square" lIns="164592" rIns="164592" tIns="164592" bIns="164592"/>
+          <a:lstStyle/>
+          <a:p>
+            <a:pPr algn="l">
+              <a:spcAft>
+                <a:spcPts val="400"/>
+              </a:spcAft>
+            </a:pPr>
+            <a:r>
+              <a:rPr sz="1500" b="1">
+                <a:solidFill>
+                  <a:srgbClr val="1F4E79"/>
+                </a:solidFill>
+                <a:latin typeface="Calibri"/>
+              </a:rPr>
+              <a:t>What the screens show</a:t>
+            </a:r>
+          </a:p>
+          <a:p>
+            <a:pPr algn="l" marL="201168" indent="-182880">
+              <a:spcAft>
+                <a:spcPts val="400"/>
+              </a:spcAft>
+              <a:buChar char="•"/>
+            </a:pPr>
+            <a:r>
+              <a:rPr sz="1200" b="0">
+                <a:solidFill>
+                  <a:srgbClr val="1F2937"/>
+                </a:solidFill>
+                <a:latin typeface="Calibri"/>
+              </a:rPr>
+              <a:t>AI output is always labelled and never approves, verifies or closes</a:t>
+            </a:r>
+          </a:p>
+          <a:p>
+            <a:pPr algn="l" marL="201168" indent="-182880">
+              <a:spcAft>
+                <a:spcPts val="400"/>
+              </a:spcAft>
+              <a:buChar char="•"/>
+            </a:pPr>
+            <a:r>
+              <a:rPr sz="1200" b="0">
+                <a:solidFill>
+                  <a:srgbClr val="1F2937"/>
+                </a:solidFill>
+                <a:latin typeface="Calibri"/>
+              </a:rPr>
+              <a:t>Answers and requirements cite retrieved passages only</a:t>
+            </a:r>
+          </a:p>
+          <a:p>
+            <a:pPr algn="l" marL="201168" indent="-182880">
+              <a:spcAft>
+                <a:spcPts val="400"/>
+              </a:spcAft>
+              <a:buChar char="•"/>
+            </a:pPr>
+            <a:r>
+              <a:rPr sz="1200" b="0">
+                <a:solidFill>
+                  <a:srgbClr val="1F2937"/>
+                </a:solidFill>
+                <a:latin typeface="Calibri"/>
+              </a:rPr>
+              <a:t>Role checks happen in the API; the browser only renders what it is allowed</a:t>
+            </a:r>
+          </a:p>
+        </p:txBody>
+      </p:sp>
+    </p:spTree>
+    <p:extLst>
+      <p:ext uri="{BB962C8B-B14F-4D97-AF65-F5344CB8AC3E}">
+        <p14:creationId xmlns:p14="http://schemas.microsoft.com/office/powerpoint/2010/main" val="679362563"/>
+      </p:ext>
+    </p:extLst>
+  </p:cSld>
+  <p:clrMapOvr>
+    <a:masterClrMapping/>
+  </p:clrMapOvr>
+  <mc:AlternateContent xmlns:mc="http://schemas.openxmlformats.org/markup-compatibility/2006" xmlns:p14="http://schemas.microsoft.com/office/powerpoint/2010/main">
+    <mc:Choice Requires="p14">
+      <p:transition spd="med" p14:dur="700">
+        <p:fade/>
+      </p:transition>
+    </mc:Choice>
+    <mc:Fallback xmlns="">
+      <p:transition spd="med">
+        <p:fade/>
+      </p:transition>
+    </mc:Fallback>
+  </mc:AlternateContent>
+</p:sld>
+</file>
+
+<file path=ppt/slides/slide15.xml><?xml version="1.0" encoding="utf-8"?>
 <p:sld xmlns:a="http://schemas.openxmlformats.org/drawingml/2006/main" xmlns:r="http://schemas.openxmlformats.org/officeDocument/2006/relationships" xmlns:p="http://schemas.openxmlformats.org/presentationml/2006/main">
   <p:cSld>
     <p:spTree>
@@ -10341,7 +11341,7 @@
                 </a:solidFill>
                 <a:latin typeface="Calibri"/>
               </a:rPr>
-              <a:t>255</a:t>
+              <a:t>267</a:t>
             </a:r>
           </a:p>
         </p:txBody>
@@ -10799,7 +11799,7 @@
 </p:sld>
 </file>
 
-<file path=ppt/slides/slide14.xml><?xml version="1.0" encoding="utf-8"?>
+<file path=ppt/slides/slide16.xml><?xml version="1.0" encoding="utf-8"?>
 <p:sld xmlns:a="http://schemas.openxmlformats.org/drawingml/2006/main" xmlns:r="http://schemas.openxmlformats.org/officeDocument/2006/relationships" xmlns:p="http://schemas.openxmlformats.org/presentationml/2006/main">
   <p:cSld>
     <p:spTree>
@@ -11998,7 +12998,7 @@
 </p:sld>
 </file>
 
-<file path=ppt/slides/slide15.xml><?xml version="1.0" encoding="utf-8"?>
+<file path=ppt/slides/slide17.xml><?xml version="1.0" encoding="utf-8"?>
 <p:sld xmlns:a="http://schemas.openxmlformats.org/drawingml/2006/main" xmlns:r="http://schemas.openxmlformats.org/officeDocument/2006/relationships" xmlns:p="http://schemas.openxmlformats.org/presentationml/2006/main">
   <p:cSld>
     <p:spTree>
@@ -12297,7 +13297,7 @@
 </p:sld>
 </file>
 
-<file path=ppt/slides/slide16.xml><?xml version="1.0" encoding="utf-8"?>
+<file path=ppt/slides/slide18.xml><?xml version="1.0" encoding="utf-8"?>
 <p:sld xmlns:a="http://schemas.openxmlformats.org/drawingml/2006/main" xmlns:r="http://schemas.openxmlformats.org/officeDocument/2006/relationships" xmlns:p="http://schemas.openxmlformats.org/presentationml/2006/main">
   <p:cSld>
     <p:spTree>

</xml_diff>